<commit_message>
fix: Streamlit Cloud import bootstrap + disclosed-assumptions in docs
- dashboard: repo root onto sys.path + cwd pin — Data Provenance /
  weight sensitivity / campaign measurement crashed on Streamlit Cloud
  (ModuleNotFoundError: src.*); verified via AppTest from foreign cwd
- methodology v2.0: 'Disclosed Assumptions — Know Them Cold' section
  incl. the scripted weakest-data answer
- deck: 'Disclosed by design' strip on the trust slide + Q&A script in
  speaker notes
</commit_message>
<xml_diff>
--- a/SPPF_IQVIA_Ideathon_Deck.pptx
+++ b/SPPF_IQVIA_Ideathon_Deck.pptx
@@ -1304,7 +1304,7 @@
           <a:p>
             <a:r>
               <a:rPr lang="en-US" dirty="0"/>
-              <a:t>Every check class here corresponds to a real bug we found and killed during the platform audit — wrong Census columns, comma-mangled CMS numerics, CDC's rolling dataset IDs. The QA gate caught the last one in production before it shipped. That story lands well with data-quality-scarred analysts.</a:t>
+              <a:t>Every check class here corresponds to a real bug we found and killed during the platform audit — wrong Census columns, comma-mangled CMS numerics, CDC's rolling dataset IDs. The QA gate caught the last one in production before it shipped. If a judge asks 'what's the weakest part of your data?', the scripted answer: 'Payer mix beyond MA penetration is modeled, and hypothyroidism is a proxy — both labeled as such in the app. That's why the provenance page exists: we'd rather show you the seams than have you find them.' Honesty as a feature. Also know cold: pool estimates apply uniform national undiagnosis rates; Diagnosis Gap currently runs on its CDC-only fallback (full CMS GV PUF endpoint is a data-refresh roadmap item — the code supports it already); ZIP payer/trajectory dims are county downscales; dimension and specialty-fit weights are judgment calls defended by the live sensitivity analysis.</a:t>
             </a:r>
             <a:endParaRPr lang="en-US" dirty="0"/>
           </a:p>
@@ -7661,12 +7661,12 @@
         </p:nvSpPr>
         <p:spPr>
           <a:xfrm>
-            <a:off x="502920" y="1325880"/>
-            <a:ext cx="4041648" cy="1517904"/>
+            <a:off x="502920" y="1298448"/>
+            <a:ext cx="4041648" cy="1463040"/>
           </a:xfrm>
           <a:prstGeom prst="roundRect">
             <a:avLst>
-              <a:gd name="adj" fmla="val 4217"/>
+              <a:gd name="adj" fmla="val 4375"/>
             </a:avLst>
           </a:prstGeom>
           <a:solidFill>
@@ -7690,7 +7690,7 @@
         </p:nvSpPr>
         <p:spPr>
           <a:xfrm>
-            <a:off x="667512" y="1490472"/>
+            <a:off x="667512" y="1444752"/>
             <a:ext cx="475488" cy="475488"/>
           </a:xfrm>
           <a:prstGeom prst="ellipse">
@@ -7718,7 +7718,7 @@
         </p:blipFill>
         <p:spPr>
           <a:xfrm>
-            <a:off x="781629" y="1604589"/>
+            <a:off x="781629" y="1558869"/>
             <a:ext cx="247254" cy="247254"/>
           </a:xfrm>
           <a:prstGeom prst="rect">
@@ -7734,7 +7734,7 @@
         </p:nvSpPr>
         <p:spPr>
           <a:xfrm>
-            <a:off x="1280160" y="1481328"/>
+            <a:off x="1280160" y="1435608"/>
             <a:ext cx="3154680" cy="310896"/>
           </a:xfrm>
           <a:prstGeom prst="rect">
@@ -7770,8 +7770,8 @@
         </p:nvSpPr>
         <p:spPr>
           <a:xfrm>
-            <a:off x="1280160" y="1810512"/>
-            <a:ext cx="3154680" cy="960120"/>
+            <a:off x="1280160" y="1755648"/>
+            <a:ext cx="3154680" cy="932688"/>
           </a:xfrm>
           <a:prstGeom prst="rect">
             <a:avLst/>
@@ -7806,12 +7806,12 @@
         </p:nvSpPr>
         <p:spPr>
           <a:xfrm>
-            <a:off x="4727448" y="1325880"/>
-            <a:ext cx="4041648" cy="1517904"/>
+            <a:off x="4727448" y="1298448"/>
+            <a:ext cx="4041648" cy="1463040"/>
           </a:xfrm>
           <a:prstGeom prst="roundRect">
             <a:avLst>
-              <a:gd name="adj" fmla="val 4217"/>
+              <a:gd name="adj" fmla="val 4375"/>
             </a:avLst>
           </a:prstGeom>
           <a:solidFill>
@@ -7835,7 +7835,7 @@
         </p:nvSpPr>
         <p:spPr>
           <a:xfrm>
-            <a:off x="4892040" y="1490472"/>
+            <a:off x="4892040" y="1444752"/>
             <a:ext cx="475488" cy="475488"/>
           </a:xfrm>
           <a:prstGeom prst="ellipse">
@@ -7863,7 +7863,7 @@
         </p:blipFill>
         <p:spPr>
           <a:xfrm>
-            <a:off x="5006157" y="1604589"/>
+            <a:off x="5006157" y="1558869"/>
             <a:ext cx="247254" cy="247254"/>
           </a:xfrm>
           <a:prstGeom prst="rect">
@@ -7879,7 +7879,7 @@
         </p:nvSpPr>
         <p:spPr>
           <a:xfrm>
-            <a:off x="5504688" y="1481328"/>
+            <a:off x="5504688" y="1435608"/>
             <a:ext cx="3154680" cy="310896"/>
           </a:xfrm>
           <a:prstGeom prst="rect">
@@ -7915,8 +7915,8 @@
         </p:nvSpPr>
         <p:spPr>
           <a:xfrm>
-            <a:off x="5504688" y="1810512"/>
-            <a:ext cx="3154680" cy="960120"/>
+            <a:off x="5504688" y="1755648"/>
+            <a:ext cx="3154680" cy="932688"/>
           </a:xfrm>
           <a:prstGeom prst="rect">
             <a:avLst/>
@@ -7951,12 +7951,12 @@
         </p:nvSpPr>
         <p:spPr>
           <a:xfrm>
-            <a:off x="502920" y="3017520"/>
-            <a:ext cx="4041648" cy="1517904"/>
+            <a:off x="502920" y="2926080"/>
+            <a:ext cx="4041648" cy="1463040"/>
           </a:xfrm>
           <a:prstGeom prst="roundRect">
             <a:avLst>
-              <a:gd name="adj" fmla="val 4217"/>
+              <a:gd name="adj" fmla="val 4375"/>
             </a:avLst>
           </a:prstGeom>
           <a:solidFill>
@@ -7980,7 +7980,7 @@
         </p:nvSpPr>
         <p:spPr>
           <a:xfrm>
-            <a:off x="667512" y="3182112"/>
+            <a:off x="667512" y="3072384"/>
             <a:ext cx="475488" cy="475488"/>
           </a:xfrm>
           <a:prstGeom prst="ellipse">
@@ -8008,7 +8008,7 @@
         </p:blipFill>
         <p:spPr>
           <a:xfrm>
-            <a:off x="781629" y="3296229"/>
+            <a:off x="781629" y="3186501"/>
             <a:ext cx="247254" cy="247254"/>
           </a:xfrm>
           <a:prstGeom prst="rect">
@@ -8024,7 +8024,7 @@
         </p:nvSpPr>
         <p:spPr>
           <a:xfrm>
-            <a:off x="1280160" y="3172968"/>
+            <a:off x="1280160" y="3063240"/>
             <a:ext cx="3154680" cy="310896"/>
           </a:xfrm>
           <a:prstGeom prst="rect">
@@ -8060,8 +8060,8 @@
         </p:nvSpPr>
         <p:spPr>
           <a:xfrm>
-            <a:off x="1280160" y="3502152"/>
-            <a:ext cx="3154680" cy="960120"/>
+            <a:off x="1280160" y="3383280"/>
+            <a:ext cx="3154680" cy="932688"/>
           </a:xfrm>
           <a:prstGeom prst="rect">
             <a:avLst/>
@@ -8096,12 +8096,12 @@
         </p:nvSpPr>
         <p:spPr>
           <a:xfrm>
-            <a:off x="4727448" y="3017520"/>
-            <a:ext cx="4041648" cy="1517904"/>
+            <a:off x="4727448" y="2926080"/>
+            <a:ext cx="4041648" cy="1463040"/>
           </a:xfrm>
           <a:prstGeom prst="roundRect">
             <a:avLst>
-              <a:gd name="adj" fmla="val 4217"/>
+              <a:gd name="adj" fmla="val 4375"/>
             </a:avLst>
           </a:prstGeom>
           <a:solidFill>
@@ -8125,7 +8125,7 @@
         </p:nvSpPr>
         <p:spPr>
           <a:xfrm>
-            <a:off x="4892040" y="3182112"/>
+            <a:off x="4892040" y="3072384"/>
             <a:ext cx="475488" cy="475488"/>
           </a:xfrm>
           <a:prstGeom prst="ellipse">
@@ -8153,7 +8153,7 @@
         </p:blipFill>
         <p:spPr>
           <a:xfrm>
-            <a:off x="5006157" y="3296229"/>
+            <a:off x="5006157" y="3186501"/>
             <a:ext cx="247254" cy="247254"/>
           </a:xfrm>
           <a:prstGeom prst="rect">
@@ -8169,7 +8169,7 @@
         </p:nvSpPr>
         <p:spPr>
           <a:xfrm>
-            <a:off x="5504688" y="3172968"/>
+            <a:off x="5504688" y="3063240"/>
             <a:ext cx="3154680" cy="310896"/>
           </a:xfrm>
           <a:prstGeom prst="rect">
@@ -8205,8 +8205,8 @@
         </p:nvSpPr>
         <p:spPr>
           <a:xfrm>
-            <a:off x="5504688" y="3502152"/>
-            <a:ext cx="3154680" cy="960120"/>
+            <a:off x="5504688" y="3383280"/>
+            <a:ext cx="3154680" cy="932688"/>
           </a:xfrm>
           <a:prstGeom prst="rect">
             <a:avLst/>
@@ -8230,6 +8230,75 @@
               <a:t>Buyer-facing 0–100 percentile ranks, uncertainty acknowledged, weight sensitivity exposed — no black box anywhere.</a:t>
             </a:r>
             <a:endParaRPr lang="en-US" sz="1000" dirty="0"/>
+          </a:p>
+        </p:txBody>
+      </p:sp>
+      <p:sp>
+        <p:nvSpPr>
+          <p:cNvPr id="24" name="Shape 18"/>
+          <p:cNvSpPr/>
+          <p:nvPr/>
+        </p:nvSpPr>
+        <p:spPr>
+          <a:xfrm>
+            <a:off x="502920" y="4590288"/>
+            <a:ext cx="8247888" cy="457200"/>
+          </a:xfrm>
+          <a:prstGeom prst="roundRect">
+            <a:avLst>
+              <a:gd name="adj" fmla="val 12000"/>
+            </a:avLst>
+          </a:prstGeom>
+          <a:solidFill>
+            <a:srgbClr val="EAF6F4"/>
+          </a:solidFill>
+          <a:ln/>
+        </p:spPr>
+      </p:sp>
+      <p:sp>
+        <p:nvSpPr>
+          <p:cNvPr id="25" name="Text 19"/>
+          <p:cNvSpPr/>
+          <p:nvPr/>
+        </p:nvSpPr>
+        <p:spPr>
+          <a:xfrm>
+            <a:off x="658368" y="4590288"/>
+            <a:ext cx="7955280" cy="457200"/>
+          </a:xfrm>
+          <a:prstGeom prst="rect">
+            <a:avLst/>
+          </a:prstGeom>
+          <a:noFill/>
+          <a:ln/>
+        </p:spPr>
+        <p:txBody>
+          <a:bodyPr wrap="square" lIns="0" tIns="0" rIns="0" bIns="0" rtlCol="0" anchor="ctr"/>
+          <a:lstStyle/>
+          <a:p>
+            <a:pPr indent="0" marL="0">
+              <a:buNone/>
+            </a:pPr>
+            <a:r>
+              <a:rPr lang="en-US" sz="950" b="1" dirty="0">
+                <a:solidFill>
+                  <a:srgbClr val="2A9D8F"/>
+                </a:solidFill>
+              </a:rPr>
+              <a:t>Disclosed by design: </a:t>
+            </a:r>
+            <a:pPr indent="0" marL="0">
+              <a:buNone/>
+            </a:pPr>
+            <a:r>
+              <a:rPr lang="en-US" sz="950" dirty="0">
+                <a:solidFill>
+                  <a:srgbClr val="5A6478"/>
+                </a:solidFill>
+              </a:rPr>
+              <a:t>pool estimates use national undiagnosis rates · payer mix beyond MA penetration is modeled · hypothyroidism is a proxy · ZIP payer/trend dims are county downscales — every assumption is labeled in the app itself.</a:t>
+            </a:r>
+            <a:endParaRPr lang="en-US" sz="950" dirty="0"/>
           </a:p>
         </p:txBody>
       </p:sp>

</xml_diff>